<commit_message>
Stage 8 review fixes: A-011
</commit_message>
<xml_diff>
--- a/output/archive/Archive/Users/omerriman_old_laptop/Integration/2022/Copy of Brindlewythe_intake_09Jun22.pptx
+++ b/output/archive/Archive/Users/omerriman_old_laptop/Integration/2022/Copy of Brindlewythe_intake_09Jun22.pptx
@@ -13,7 +13,7 @@
     <p:sldId id="261" r:id="rId12"/>
     <p:sldId id="262" r:id="rId13"/>
     <p:sldId id="263" r:id="rId14"/>
-    <p:sldId id="264" r:id="rId15"/>
+    <p:sldId id="264" r:id="rId16"/>
   </p:sldIdLst>
   <p:sldSz cx="12191695" cy="6858000" type="screen4x3"/>
   <p:notesSz cx="6858000" cy="9144000"/>
@@ -510,7 +510,77 @@
           <a:lstStyle/>
           <a:p>
             <a:r>
-              <a:t>Adapted from the Brindlewythe 2021 intake pack. Remove any leftover wording from that pack before this goes to new starters.</a:t>
+              <a:t>Copied contact box is obsolete. Andrew May and Clara Fenwick are Vellacombe handover annotations; confirm the source contacts before reissuing.</a:t>
+            </a:r>
+          </a:p>
+        </p:txBody>
+      </p:sp>
+      <p:sp>
+        <p:nvSpPr>
+          <p:cNvPr id="4" name="Slide Number Placeholder 3"/>
+          <p:cNvSpPr>
+            <a:spLocks noGrp="1"/>
+          </p:cNvSpPr>
+          <p:nvPr>
+            <p:ph type="sldNum" idx="5" sz="quarter"/>
+          </p:nvPr>
+        </p:nvSpPr>
+        <p:spPr/>
+      </p:sp>
+    </p:spTree>
+  </p:cSld>
+  <p:clrMapOvr>
+    <a:masterClrMapping/>
+  </p:clrMapOvr>
+</p:notes>
+</file>
+
+<file path=ppt/notesSlides/notesSlide2.xml><?xml version="1.0" encoding="utf-8"?>
+<p:notes xmlns:a="http://schemas.openxmlformats.org/drawingml/2006/main" xmlns:p="http://schemas.openxmlformats.org/presentationml/2006/main" xmlns:r="http://schemas.openxmlformats.org/officeDocument/2006/relationships">
+  <p:cSld>
+    <p:spTree>
+      <p:nvGrpSpPr>
+        <p:cNvPr id="1" name=""/>
+        <p:cNvGrpSpPr/>
+        <p:nvPr/>
+      </p:nvGrpSpPr>
+      <p:grpSpPr>
+        <a:xfrm>
+          <a:off x="0" y="0"/>
+          <a:ext cx="0" cy="0"/>
+          <a:chOff x="0" y="0"/>
+          <a:chExt cx="0" cy="0"/>
+        </a:xfrm>
+      </p:grpSpPr>
+      <p:sp>
+        <p:nvSpPr>
+          <p:cNvPr id="2" name="Slide Image Placeholder 1"/>
+          <p:cNvSpPr>
+            <a:spLocks noGrp="1"/>
+          </p:cNvSpPr>
+          <p:nvPr>
+            <p:ph type="sldImg" idx="2"/>
+          </p:nvPr>
+        </p:nvSpPr>
+        <p:spPr/>
+      </p:sp>
+      <p:sp>
+        <p:nvSpPr>
+          <p:cNvPr id="3" name="Notes Placeholder 2"/>
+          <p:cNvSpPr>
+            <a:spLocks noGrp="1"/>
+          </p:cNvSpPr>
+          <p:nvPr>
+            <p:ph type="body" idx="3" sz="quarter"/>
+          </p:nvPr>
+        </p:nvSpPr>
+        <p:spPr/>
+        <p:txBody>
+          <a:bodyPr/>
+          <a:lstStyle/>
+          <a:p>
+            <a:r>
+              <a:t>Copied from Brindlewythe 2021 intake training. Vellacombe handover: check accession and storage instructions locally before reuse. Personal copy only.</a:t>
             </a:r>
           </a:p>
         </p:txBody>
@@ -3618,7 +3688,7 @@
                 </a:solidFill>
                 <a:latin typeface="Arial"/>
               </a:rPr>
-              <a:t>Vellacombe Discovery Ltd, a Tarnovell company | 09 Jun 2022</a:t>
+              <a:t>Vellacombe Discovery Ltd, a Tarnovell company | 09 Jun 2022 | Copy of Brindlewythe 2021 training — superseded working copy</a:t>
             </a:r>
           </a:p>
         </p:txBody>
@@ -3897,7 +3967,7 @@
               <a:rPr sz="1700">
                 <a:latin typeface="Arial"/>
               </a:rPr>
-              <a:t>Cold-chain items go straight to the controlled storage room</a:t>
+              <a:t>Cold-chain items go promptly to storage at the temperature specified for the sample</a:t>
             </a:r>
           </a:p>
           <a:p>
@@ -4084,7 +4154,7 @@
               <a:rPr sz="1800">
                 <a:latin typeface="Arial"/>
               </a:rPr>
-              <a:t>Container type and fill volume recorded in mg or mL</a:t>
+              <a:t>Container type recorded separately from sample mass (mg) or liquid volume (mL)</a:t>
             </a:r>
           </a:p>
         </p:txBody>
@@ -4426,7 +4496,7 @@
                         <a:rPr sz="1400">
                           <a:latin typeface="Arial"/>
                         </a:rPr>
-                        <a:t>Ambient, desiccated cabinet</a:t>
+                        <a:t>As specified on the sample instructions</a:t>
                       </a:r>
                     </a:p>
                   </a:txBody>
@@ -4441,7 +4511,7 @@
                         <a:rPr sz="1400">
                           <a:latin typeface="Arial"/>
                         </a:rPr>
-                        <a:t>Label legible on receipt</a:t>
+                        <a:t>Confirm moisture and temperature requirements</a:t>
                       </a:r>
                     </a:p>
                   </a:txBody>
@@ -4473,7 +4543,7 @@
                         <a:rPr sz="1400">
                           <a:latin typeface="Arial"/>
                         </a:rPr>
-                        <a:t>Freezer, screw-cap vials</a:t>
+                        <a:t>As specified on the sample instructions</a:t>
                       </a:r>
                     </a:p>
                   </a:txBody>
@@ -4488,7 +4558,7 @@
                         <a:rPr sz="1400">
                           <a:latin typeface="Arial"/>
                         </a:rPr>
-                        <a:t>Seal checked at logging</a:t>
+                        <a:t>Confirm temperature; check seal at logging</a:t>
                       </a:r>
                     </a:p>
                   </a:txBody>
@@ -4520,7 +4590,7 @@
                         <a:rPr sz="1400">
                           <a:latin typeface="Arial"/>
                         </a:rPr>
-                        <a:t>Amber vials, dark cabinet</a:t>
+                        <a:t>Light-protected storage as specified</a:t>
                       </a:r>
                     </a:p>
                   </a:txBody>
@@ -4535,7 +4605,7 @@
                         <a:rPr sz="1400">
                           <a:latin typeface="Arial"/>
                         </a:rPr>
-                        <a:t>Wrapped before storage</a:t>
+                        <a:t>Confirm temperature as well as light protection</a:t>
                       </a:r>
                     </a:p>
                   </a:txBody>
@@ -4567,7 +4637,7 @@
                         <a:rPr sz="1400">
                           <a:latin typeface="Arial"/>
                         </a:rPr>
-                        <a:t>Controlled storage room</a:t>
+                        <a:t>Storage at the specified temperature</a:t>
                       </a:r>
                     </a:p>
                   </a:txBody>
@@ -4582,7 +4652,7 @@
                         <a:rPr sz="1400">
                           <a:latin typeface="Arial"/>
                         </a:rPr>
-                        <a:t>Temperature log initialled</a:t>
+                        <a:t>Receipt condition and temperature log recorded</a:t>
                       </a:r>
                     </a:p>
                   </a:txBody>

</xml_diff>